<commit_message>
added link to tool
</commit_message>
<xml_diff>
--- a/Loan Option Evaluation.pptx
+++ b/Loan Option Evaluation.pptx
@@ -112,6 +112,11 @@
       </a:defRPr>
     </a:lvl9pPr>
   </p:defaultTextStyle>
+  <p:extLst>
+    <p:ext uri="{EFAFB233-063F-42B5-8137-9DF3F51BA10A}">
+      <p15:sldGuideLst xmlns:p15="http://schemas.microsoft.com/office/powerpoint/2012/main"/>
+    </p:ext>
+  </p:extLst>
 </p:presentation>
 </file>
 
@@ -704,7 +709,7 @@
           <a:p>
             <a:fld id="{D1D1EADE-8E88-4C7C-8AC5-FB148DE4940E}" type="datetime1">
               <a:rPr lang="en-US" smtClean="0"/>
-              <a:t>6/18/2026</a:t>
+              <a:t>6/22/2026</a:t>
             </a:fld>
             <a:endParaRPr lang="en-US"/>
           </a:p>
@@ -904,7 +909,7 @@
           <a:p>
             <a:fld id="{EC3C8B9C-477D-492A-96AD-1FC2CC997A73}" type="datetime1">
               <a:rPr lang="en-US" smtClean="0"/>
-              <a:t>6/18/2026</a:t>
+              <a:t>6/22/2026</a:t>
             </a:fld>
             <a:endParaRPr lang="en-US"/>
           </a:p>
@@ -1114,7 +1119,7 @@
           <a:p>
             <a:fld id="{42D3AED5-E26D-4E29-B1B3-7847B6779594}" type="datetime1">
               <a:rPr lang="en-US" smtClean="0"/>
-              <a:t>6/18/2026</a:t>
+              <a:t>6/22/2026</a:t>
             </a:fld>
             <a:endParaRPr lang="en-US"/>
           </a:p>
@@ -1314,7 +1319,7 @@
           <a:p>
             <a:fld id="{157B6794-849E-4626-908B-D15793550EFB}" type="datetime1">
               <a:rPr lang="en-US" smtClean="0"/>
-              <a:t>6/18/2026</a:t>
+              <a:t>6/22/2026</a:t>
             </a:fld>
             <a:endParaRPr lang="en-US"/>
           </a:p>
@@ -1590,7 +1595,7 @@
           <a:p>
             <a:fld id="{63DB64E7-5594-42A3-ADBF-E95A7ACEAD64}" type="datetime1">
               <a:rPr lang="en-US" smtClean="0"/>
-              <a:t>6/18/2026</a:t>
+              <a:t>6/22/2026</a:t>
             </a:fld>
             <a:endParaRPr lang="en-US"/>
           </a:p>
@@ -1863,7 +1868,7 @@
           <a:p>
             <a:fld id="{18462B0B-D248-4FFB-8695-AD7FA4B1284A}" type="datetime1">
               <a:rPr lang="en-US" smtClean="0"/>
-              <a:t>6/18/2026</a:t>
+              <a:t>6/22/2026</a:t>
             </a:fld>
             <a:endParaRPr lang="en-US"/>
           </a:p>
@@ -2286,7 +2291,7 @@
           <a:p>
             <a:fld id="{D0378EFB-9159-4510-B73F-4F0409ADE937}" type="datetime1">
               <a:rPr lang="en-US" smtClean="0"/>
-              <a:t>6/18/2026</a:t>
+              <a:t>6/22/2026</a:t>
             </a:fld>
             <a:endParaRPr lang="en-US"/>
           </a:p>
@@ -2428,7 +2433,7 @@
           <a:p>
             <a:fld id="{89BC9412-2452-4BED-A324-9D8C115361AD}" type="datetime1">
               <a:rPr lang="en-US" smtClean="0"/>
-              <a:t>6/18/2026</a:t>
+              <a:t>6/22/2026</a:t>
             </a:fld>
             <a:endParaRPr lang="en-US"/>
           </a:p>
@@ -2541,7 +2546,7 @@
           <a:p>
             <a:fld id="{F5318F62-D251-40E8-A23C-F4CFE9FEAB41}" type="datetime1">
               <a:rPr lang="en-US" smtClean="0"/>
-              <a:t>6/18/2026</a:t>
+              <a:t>6/22/2026</a:t>
             </a:fld>
             <a:endParaRPr lang="en-US"/>
           </a:p>
@@ -2854,7 +2859,7 @@
           <a:p>
             <a:fld id="{44F76144-149E-4874-93A5-554A0357CF82}" type="datetime1">
               <a:rPr lang="en-US" smtClean="0"/>
-              <a:t>6/18/2026</a:t>
+              <a:t>6/22/2026</a:t>
             </a:fld>
             <a:endParaRPr lang="en-US"/>
           </a:p>
@@ -3147,7 +3152,7 @@
           <a:p>
             <a:fld id="{50BA65D8-0540-4835-AE5C-25D29DBA01BE}" type="datetime1">
               <a:rPr lang="en-US" smtClean="0"/>
-              <a:t>6/18/2026</a:t>
+              <a:t>6/22/2026</a:t>
             </a:fld>
             <a:endParaRPr lang="en-US"/>
           </a:p>
@@ -3389,7 +3394,7 @@
           <a:p>
             <a:fld id="{E31BA835-12AC-4E8F-955A-EA3F4DE2791F}" type="datetime1">
               <a:rPr lang="en-US" smtClean="0"/>
-              <a:t>6/18/2026</a:t>
+              <a:t>6/22/2026</a:t>
             </a:fld>
             <a:endParaRPr lang="en-US"/>
           </a:p>
@@ -6375,6 +6380,44 @@
               <a:rPr lang="en-US" sz="1000" dirty="0"/>
               <a:t>Linear Regression Analysis</a:t>
             </a:r>
+          </a:p>
+        </p:txBody>
+      </p:sp>
+      <p:sp>
+        <p:nvSpPr>
+          <p:cNvPr id="3" name="TextBox 2">
+            <a:extLst>
+              <a:ext uri="{FF2B5EF4-FFF2-40B4-BE49-F238E27FC236}">
+                <a16:creationId xmlns:a16="http://schemas.microsoft.com/office/drawing/2014/main" id="{619E84EC-1033-7E06-BC51-5B349AE58B5A}"/>
+              </a:ext>
+            </a:extLst>
+          </p:cNvPr>
+          <p:cNvSpPr txBox="1"/>
+          <p:nvPr/>
+        </p:nvSpPr>
+        <p:spPr>
+          <a:xfrm>
+            <a:off x="9899010" y="6359402"/>
+            <a:ext cx="2043056" cy="261610"/>
+          </a:xfrm>
+          <a:prstGeom prst="rect">
+            <a:avLst/>
+          </a:prstGeom>
+          <a:noFill/>
+        </p:spPr>
+        <p:txBody>
+          <a:bodyPr wrap="square" rtlCol="0">
+            <a:spAutoFit/>
+          </a:bodyPr>
+          <a:lstStyle/>
+          <a:p>
+            <a:r>
+              <a:rPr lang="en-US" sz="1100" dirty="0">
+                <a:hlinkClick r:id="rId2"/>
+              </a:rPr>
+              <a:t>Loan Interest Rate Predictor</a:t>
+            </a:r>
+            <a:endParaRPr lang="en-US" sz="1100" dirty="0"/>
           </a:p>
         </p:txBody>
       </p:sp>

</xml_diff>